<commit_message>
Add bounded Zetaris follow-up investigation
</commit_message>
<xml_diff>
--- a/docs/Lens_Open_Agent_Hackathon_2026.pptx
+++ b/docs/Lens_Open_Agent_Hackathon_2026.pptx
@@ -6230,7 +6230,7 @@
               </a:defRPr>
             </a:pPr>
             <a:r>
-              <a:t>Evidence retrieval and checking have distinct jobs</a:t>
+              <a:t>Lens chooses one bounded evidence follow-up</a:t>
             </a:r>
           </a:p>
         </p:txBody>
@@ -6269,7 +6269,7 @@
               </a:defRPr>
             </a:pPr>
             <a:r>
-              <a:t>Python HTTP app and SQLite review; browser UI in HTML, CSS and JavaScript.</a:t>
+              <a:t>Deterministic planner and arithmetic; Python HTTP app, SQLite review, browser UI.</a:t>
             </a:r>
           </a:p>
         </p:txBody>
@@ -6640,7 +6640,7 @@
               </a:defRPr>
             </a:pPr>
             <a:r>
-              <a:t>Validate the snapshot; link claims to sources; calculate cross-grant totals</a:t>
+              <a:t>Check cross-grant totals; choose a follow-up from the finding; reread only relevant tables</a:t>
             </a:r>
           </a:p>
         </p:txBody>
@@ -6845,7 +6845,7 @@
               </a:defRPr>
             </a:pPr>
             <a:r>
-              <a:t>A reviewer checks the source, corrects or explains, and reruns the review.</a:t>
+              <a:t>After a correction, the next open finding can trigger a different evidence query.</a:t>
             </a:r>
           </a:p>
         </p:txBody>
@@ -6992,7 +6992,7 @@
               </a:defRPr>
             </a:pPr>
             <a:r>
-              <a:t>Verified 24 October 2026 with synthetic grant records; film the same path for submission.</a:t>
+              <a:t>Five-table import and two adaptive follow-up branches verified against live Zetaris tables; filming pending.</a:t>
             </a:r>
           </a:p>
         </p:txBody>

</xml_diff>

<commit_message>
Document sponsor proof and add bounded Nightshift routing
</commit_message>
<xml_diff>
--- a/docs/Lens_Open_Agent_Hackathon_2026.pptx
+++ b/docs/Lens_Open_Agent_Hackathon_2026.pptx
@@ -4689,7 +4689,7 @@
               </a:defRPr>
             </a:pPr>
             <a:r>
-              <a:t>The reviewer has a complete local workflow</a:t>
+              <a:t>The result puts the question before the raw rows</a:t>
             </a:r>
           </a:p>
         </p:txBody>
@@ -4728,7 +4728,7 @@
               </a:defRPr>
             </a:pPr>
             <a:r>
-              <a:t>Interface excerpt recreated with the current labels; capture a live screenshot before submission.</a:t>
+              <a:t>Actual Lens results screen, synthetic data. A reviewer can inspect evidence and act.</a:t>
             </a:r>
           </a:p>
         </p:txBody>
@@ -4772,16 +4772,40 @@
           </a:p>
         </p:txBody>
       </p:sp>
-      <p:sp>
-        <p:nvSpPr>
-          <p:cNvPr id="6" name="Rounded Rectangle 5"/>
+      <p:pic>
+        <p:nvPicPr>
+          <p:cNvPr id="6" name="Picture 5" descr="results-desktop.png"/>
+          <p:cNvPicPr>
+            <a:picLocks noChangeAspect="1"/>
+          </p:cNvPicPr>
+          <p:nvPr/>
+        </p:nvPicPr>
+        <p:blipFill>
+          <a:blip r:embed="rId2"/>
+          <a:stretch>
+            <a:fillRect/>
+          </a:stretch>
+        </p:blipFill>
+        <p:spPr>
+          <a:xfrm>
+            <a:off x="658368" y="1700784"/>
+            <a:ext cx="6510528" cy="4069080"/>
+          </a:xfrm>
+          <a:prstGeom prst="rect">
+            <a:avLst/>
+          </a:prstGeom>
+        </p:spPr>
+      </p:pic>
+      <p:sp>
+        <p:nvSpPr>
+          <p:cNvPr id="7" name="Rounded Rectangle 6"/>
           <p:cNvSpPr/>
           <p:nvPr/>
         </p:nvSpPr>
         <p:spPr>
           <a:xfrm>
-            <a:off x="658368" y="1755648"/>
-            <a:ext cx="10881360" cy="4096512"/>
+            <a:off x="7543800" y="1700784"/>
+            <a:ext cx="4005072" cy="4069080"/>
           </a:xfrm>
           <a:prstGeom prst="roundRect">
             <a:avLst>
@@ -4819,61 +4843,20 @@
       </p:sp>
       <p:sp>
         <p:nvSpPr>
-          <p:cNvPr id="7" name="TextBox 6"/>
-          <p:cNvSpPr txBox="1"/>
-          <p:nvPr/>
-        </p:nvSpPr>
-        <p:spPr>
-          <a:xfrm>
-            <a:off x="1024128" y="2011680"/>
-            <a:ext cx="9692640" cy="457200"/>
-          </a:xfrm>
-          <a:prstGeom prst="rect">
-            <a:avLst/>
-          </a:prstGeom>
-          <a:noFill/>
-        </p:spPr>
-        <p:txBody>
-          <a:bodyPr wrap="square" lIns="0" rIns="0" tIns="0" bIns="0">
-            <a:spAutoFit/>
-          </a:bodyPr>
-          <a:lstStyle/>
-          <a:p>
-            <a:pPr>
-              <a:spcAft>
-                <a:spcPts val="700"/>
-              </a:spcAft>
-              <a:defRPr sz="2400" b="1">
-                <a:solidFill>
-                  <a:srgbClr val="122331"/>
-                </a:solidFill>
-                <a:latin typeface="Aptos"/>
-              </a:defRPr>
-            </a:pPr>
-            <a:r>
-              <a:t>Bring your records together</a:t>
-            </a:r>
-          </a:p>
-        </p:txBody>
-      </p:sp>
-      <p:sp>
-        <p:nvSpPr>
-          <p:cNvPr id="8" name="Rounded Rectangle 7"/>
+          <p:cNvPr id="8" name="Rectangle 7"/>
           <p:cNvSpPr/>
           <p:nvPr/>
         </p:nvSpPr>
         <p:spPr>
           <a:xfrm>
-            <a:off x="1024128" y="2761488"/>
-            <a:ext cx="4389120" cy="530352"/>
-          </a:xfrm>
-          <a:prstGeom prst="roundRect">
-            <a:avLst>
-              <a:gd name="adj" fmla="val 12000"/>
-            </a:avLst>
+            <a:off x="7543800" y="1700784"/>
+            <a:ext cx="73152" cy="4069080"/>
+          </a:xfrm>
+          <a:prstGeom prst="rect">
+            <a:avLst/>
           </a:prstGeom>
           <a:solidFill>
-            <a:srgbClr val="ECF6F3"/>
+            <a:srgbClr val="007771"/>
           </a:solidFill>
           <a:ln>
             <a:noFill/>
@@ -4909,8 +4892,8 @@
         </p:nvSpPr>
         <p:spPr>
           <a:xfrm>
-            <a:off x="1243584" y="2852928"/>
-            <a:ext cx="3931920" cy="320040"/>
+            <a:off x="7799831" y="1929384"/>
+            <a:ext cx="3502152" cy="566928"/>
           </a:xfrm>
           <a:prstGeom prst="rect">
             <a:avLst/>
@@ -4927,74 +4910,29 @@
               <a:spcAft>
                 <a:spcPts val="700"/>
               </a:spcAft>
-              <a:defRPr sz="1500" b="1">
-                <a:solidFill>
-                  <a:srgbClr val="1F343F"/>
+              <a:defRPr sz="2100" b="1">
+                <a:solidFill>
+                  <a:srgbClr val="122331"/>
                 </a:solidFill>
                 <a:latin typeface="Aptos"/>
               </a:defRPr>
             </a:pPr>
             <a:r>
-              <a:t>Load sample case</a:t>
-            </a:r>
-          </a:p>
-        </p:txBody>
-      </p:sp>
-      <p:sp>
-        <p:nvSpPr>
-          <p:cNvPr id="10" name="Rounded Rectangle 9"/>
-          <p:cNvSpPr/>
-          <p:nvPr/>
-        </p:nvSpPr>
-        <p:spPr>
-          <a:xfrm>
-            <a:off x="1024128" y="3502152"/>
-            <a:ext cx="4389120" cy="530352"/>
-          </a:xfrm>
-          <a:prstGeom prst="roundRect">
-            <a:avLst>
-              <a:gd name="adj" fmla="val 12000"/>
-            </a:avLst>
-          </a:prstGeom>
-          <a:solidFill>
-            <a:srgbClr val="ECF6F3"/>
-          </a:solidFill>
-          <a:ln>
-            <a:noFill/>
-          </a:ln>
-        </p:spPr>
-        <p:style>
-          <a:lnRef idx="1">
-            <a:schemeClr val="accent1"/>
-          </a:lnRef>
-          <a:fillRef idx="3">
-            <a:schemeClr val="accent1"/>
-          </a:fillRef>
-          <a:effectRef idx="2">
-            <a:schemeClr val="accent1"/>
-          </a:effectRef>
-          <a:fontRef idx="minor">
-            <a:schemeClr val="lt1"/>
-          </a:fontRef>
-        </p:style>
-        <p:txBody>
-          <a:bodyPr rtlCol="0" anchor="ctr"/>
-          <a:lstStyle/>
-          <a:p>
-            <a:pPr algn="ctr"/>
-          </a:p>
-        </p:txBody>
-      </p:sp>
-      <p:sp>
-        <p:nvSpPr>
-          <p:cNvPr id="11" name="TextBox 10"/>
+              <a:t>Review path</a:t>
+            </a:r>
+          </a:p>
+        </p:txBody>
+      </p:sp>
+      <p:sp>
+        <p:nvSpPr>
+          <p:cNvPr id="10" name="TextBox 9"/>
           <p:cNvSpPr txBox="1"/>
           <p:nvPr/>
         </p:nvSpPr>
         <p:spPr>
           <a:xfrm>
-            <a:off x="1243584" y="3593592"/>
-            <a:ext cx="3931920" cy="320040"/>
+            <a:off x="7799831" y="2569464"/>
+            <a:ext cx="3502152" cy="3017520"/>
           </a:xfrm>
           <a:prstGeom prst="rect">
             <a:avLst/>
@@ -5011,7 +4949,7 @@
               <a:spcAft>
                 <a:spcPts val="700"/>
               </a:spcAft>
-              <a:defRPr sz="1500" b="1">
+              <a:defRPr sz="1700" b="0">
                 <a:solidFill>
                   <a:srgbClr val="1F343F"/>
                 </a:solidFill>
@@ -5019,167 +4957,28 @@
               </a:defRPr>
             </a:pPr>
             <a:r>
-              <a:t>Import registered Zetaris tables</a:t>
-            </a:r>
-          </a:p>
-        </p:txBody>
-      </p:sp>
-      <p:sp>
-        <p:nvSpPr>
-          <p:cNvPr id="12" name="Rounded Rectangle 11"/>
-          <p:cNvSpPr/>
-          <p:nvPr/>
-        </p:nvSpPr>
-        <p:spPr>
-          <a:xfrm>
-            <a:off x="1024128" y="4242816"/>
-            <a:ext cx="4389120" cy="530352"/>
-          </a:xfrm>
-          <a:prstGeom prst="roundRect">
-            <a:avLst>
-              <a:gd name="adj" fmla="val 12000"/>
-            </a:avLst>
-          </a:prstGeom>
-          <a:solidFill>
-            <a:srgbClr val="ECF6F3"/>
-          </a:solidFill>
-          <a:ln>
-            <a:noFill/>
-          </a:ln>
-        </p:spPr>
-        <p:style>
-          <a:lnRef idx="1">
-            <a:schemeClr val="accent1"/>
-          </a:lnRef>
-          <a:fillRef idx="3">
-            <a:schemeClr val="accent1"/>
-          </a:fillRef>
-          <a:effectRef idx="2">
-            <a:schemeClr val="accent1"/>
-          </a:effectRef>
-          <a:fontRef idx="minor">
-            <a:schemeClr val="lt1"/>
-          </a:fontRef>
-        </p:style>
-        <p:txBody>
-          <a:bodyPr rtlCol="0" anchor="ctr"/>
-          <a:lstStyle/>
-          <a:p>
-            <a:pPr algn="ctr"/>
-          </a:p>
-        </p:txBody>
-      </p:sp>
-      <p:sp>
-        <p:nvSpPr>
-          <p:cNvPr id="13" name="TextBox 12"/>
-          <p:cNvSpPr txBox="1"/>
-          <p:nvPr/>
-        </p:nvSpPr>
-        <p:spPr>
-          <a:xfrm>
-            <a:off x="1243584" y="4334255"/>
-            <a:ext cx="3931920" cy="320040"/>
-          </a:xfrm>
-          <a:prstGeom prst="rect">
-            <a:avLst/>
-          </a:prstGeom>
-          <a:noFill/>
-        </p:spPr>
-        <p:txBody>
-          <a:bodyPr wrap="square" lIns="0" rIns="0" tIns="0" bIns="0">
-            <a:spAutoFit/>
-          </a:bodyPr>
-          <a:lstStyle/>
+              <a:t>Sign in and open a case.</a:t>
+            </a:r>
+          </a:p>
           <a:p>
             <a:pPr>
               <a:spcAft>
                 <a:spcPts val="700"/>
               </a:spcAft>
-              <a:defRPr sz="1500" b="1">
+              <a:defRPr sz="1700" b="0">
                 <a:solidFill>
                   <a:srgbClr val="1F343F"/>
                 </a:solidFill>
                 <a:latin typeface="Aptos"/>
               </a:defRPr>
             </a:pPr>
-            <a:r>
-              <a:t>Check both reports</a:t>
-            </a:r>
-          </a:p>
-        </p:txBody>
-      </p:sp>
-      <p:sp>
-        <p:nvSpPr>
-          <p:cNvPr id="14" name="Rounded Rectangle 13"/>
-          <p:cNvSpPr/>
-          <p:nvPr/>
-        </p:nvSpPr>
-        <p:spPr>
-          <a:xfrm>
-            <a:off x="1024128" y="4983480"/>
-            <a:ext cx="4389120" cy="530352"/>
-          </a:xfrm>
-          <a:prstGeom prst="roundRect">
-            <a:avLst>
-              <a:gd name="adj" fmla="val 12000"/>
-            </a:avLst>
-          </a:prstGeom>
-          <a:solidFill>
-            <a:srgbClr val="ECF6F3"/>
-          </a:solidFill>
-          <a:ln>
-            <a:noFill/>
-          </a:ln>
-        </p:spPr>
-        <p:style>
-          <a:lnRef idx="1">
-            <a:schemeClr val="accent1"/>
-          </a:lnRef>
-          <a:fillRef idx="3">
-            <a:schemeClr val="accent1"/>
-          </a:fillRef>
-          <a:effectRef idx="2">
-            <a:schemeClr val="accent1"/>
-          </a:effectRef>
-          <a:fontRef idx="minor">
-            <a:schemeClr val="lt1"/>
-          </a:fontRef>
-        </p:style>
-        <p:txBody>
-          <a:bodyPr rtlCol="0" anchor="ctr"/>
-          <a:lstStyle/>
-          <a:p>
-            <a:pPr algn="ctr"/>
-          </a:p>
-        </p:txBody>
-      </p:sp>
-      <p:sp>
-        <p:nvSpPr>
-          <p:cNvPr id="15" name="TextBox 14"/>
-          <p:cNvSpPr txBox="1"/>
-          <p:nvPr/>
-        </p:nvSpPr>
-        <p:spPr>
-          <a:xfrm>
-            <a:off x="1243584" y="5074920"/>
-            <a:ext cx="3931920" cy="320040"/>
-          </a:xfrm>
-          <a:prstGeom prst="rect">
-            <a:avLst/>
-          </a:prstGeom>
-          <a:noFill/>
-        </p:spPr>
-        <p:txBody>
-          <a:bodyPr wrap="square" lIns="0" rIns="0" tIns="0" bIns="0">
-            <a:spAutoFit/>
-          </a:bodyPr>
-          <a:lstStyle/>
+          </a:p>
           <a:p>
             <a:pPr>
               <a:spcAft>
                 <a:spcPts val="700"/>
               </a:spcAft>
-              <a:defRPr sz="1500" b="1">
+              <a:defRPr sz="1700" b="0">
                 <a:solidFill>
                   <a:srgbClr val="1F343F"/>
                 </a:solidFill>
@@ -5187,54 +4986,28 @@
               </a:defRPr>
             </a:pPr>
             <a:r>
-              <a:t>Questions and supporting records</a:t>
-            </a:r>
-          </a:p>
-        </p:txBody>
-      </p:sp>
-      <p:sp>
-        <p:nvSpPr>
-          <p:cNvPr id="16" name="TextBox 15"/>
-          <p:cNvSpPr txBox="1"/>
-          <p:nvPr/>
-        </p:nvSpPr>
-        <p:spPr>
-          <a:xfrm>
-            <a:off x="6400800" y="2670048"/>
-            <a:ext cx="4389120" cy="2286000"/>
-          </a:xfrm>
-          <a:prstGeom prst="rect">
-            <a:avLst/>
-          </a:prstGeom>
-          <a:noFill/>
-        </p:spPr>
-        <p:txBody>
-          <a:bodyPr wrap="square" lIns="0" rIns="0" tIns="0" bIns="0">
-            <a:spAutoFit/>
-          </a:bodyPr>
-          <a:lstStyle/>
+              <a:t>Check both reports.</a:t>
+            </a:r>
+          </a:p>
           <a:p>
             <a:pPr>
               <a:spcAft>
                 <a:spcPts val="700"/>
               </a:spcAft>
-              <a:defRPr sz="1800" b="0">
+              <a:defRPr sz="1700" b="0">
                 <a:solidFill>
                   <a:srgbClr val="1F343F"/>
                 </a:solidFill>
                 <a:latin typeface="Aptos"/>
               </a:defRPr>
             </a:pPr>
-            <a:r>
-              <a:t>Review a finding</a:t>
-            </a:r>
           </a:p>
           <a:p>
             <a:pPr>
               <a:spcAft>
                 <a:spcPts val="700"/>
               </a:spcAft>
-              <a:defRPr sz="1800" b="0">
+              <a:defRPr sz="1700" b="0">
                 <a:solidFill>
                   <a:srgbClr val="1F343F"/>
                 </a:solidFill>
@@ -5242,7 +5015,7 @@
               </a:defRPr>
             </a:pPr>
             <a:r>
-              <a:t>Save correction</a:t>
+              <a:t>Read the 8-versus-4 question.</a:t>
             </a:r>
           </a:p>
           <a:p>
@@ -5250,23 +5023,20 @@
               <a:spcAft>
                 <a:spcPts val="700"/>
               </a:spcAft>
-              <a:defRPr sz="1800" b="0">
+              <a:defRPr sz="1700" b="0">
                 <a:solidFill>
                   <a:srgbClr val="1F343F"/>
                 </a:solidFill>
                 <a:latin typeface="Aptos"/>
               </a:defRPr>
             </a:pPr>
-            <a:r>
-              <a:t>Rerun check</a:t>
-            </a:r>
           </a:p>
           <a:p>
             <a:pPr>
               <a:spcAft>
                 <a:spcPts val="700"/>
               </a:spcAft>
-              <a:defRPr sz="1800" b="0">
+              <a:defRPr sz="1700" b="0">
                 <a:solidFill>
                   <a:srgbClr val="1F343F"/>
                 </a:solidFill>
@@ -5274,7 +5044,7 @@
               </a:defRPr>
             </a:pPr>
             <a:r>
-              <a:t>Download review JSON</a:t>
+              <a:t>Correct, rerun and export.</a:t>
             </a:r>
           </a:p>
         </p:txBody>
@@ -6230,7 +6000,7 @@
               </a:defRPr>
             </a:pPr>
             <a:r>
-              <a:t>Lens chooses one bounded evidence follow-up</a:t>
+              <a:t>Evidence and model decisions have separate jobs</a:t>
             </a:r>
           </a:p>
         </p:txBody>
@@ -6269,7 +6039,7 @@
               </a:defRPr>
             </a:pPr>
             <a:r>
-              <a:t>Deterministic planner and arithmetic; Python HTTP app, SQLite review, browser UI.</a:t>
+              <a:t>Browser UI + Python HTTP server + Supabase saved reviews; no model may rewrite a finding.</a:t>
             </a:r>
           </a:p>
         </p:txBody>
@@ -6435,7 +6205,7 @@
               </a:defRPr>
             </a:pPr>
             <a:r>
-              <a:t>Zetaris</a:t>
+              <a:t>Zetaris data</a:t>
             </a:r>
           </a:p>
         </p:txBody>
@@ -6474,7 +6244,7 @@
               </a:defRPr>
             </a:pPr>
             <a:r>
-              <a:t>Query five registered grant tables; retain source IDs, hashes and request IDs</a:t>
+              <a:t>Read five registered grant tables; retain source keys, hashes and query IDs.</a:t>
             </a:r>
           </a:p>
         </p:txBody>
@@ -6601,7 +6371,7 @@
               </a:defRPr>
             </a:pPr>
             <a:r>
-              <a:t>Lens</a:t>
+              <a:t>Lens + Nightshift</a:t>
             </a:r>
           </a:p>
         </p:txBody>
@@ -6640,7 +6410,7 @@
               </a:defRPr>
             </a:pPr>
             <a:r>
-              <a:t>Check cross-grant totals; choose a follow-up from the finding; reread only relevant tables</a:t>
+              <a:t>Lens checks arithmetic. A configured Nightshift model prioritizes one bounded follow-up; live proof pending.</a:t>
             </a:r>
           </a:p>
         </p:txBody>
@@ -6767,7 +6537,7 @@
               </a:defRPr>
             </a:pPr>
             <a:r>
-              <a:t>Meterless</a:t>
+              <a:t>World Model</a:t>
             </a:r>
           </a:p>
         </p:txBody>
@@ -6806,7 +6576,7 @@
               </a:defRPr>
             </a:pPr>
             <a:r>
-              <a:t>Record source, finding and reviewer events in the local reference runtime</a:t>
+              <a:t>Meterless reference runtime links source, finding and reviewer events. Supabase saves public reviews.</a:t>
             </a:r>
           </a:p>
         </p:txBody>
@@ -6845,7 +6615,7 @@
               </a:defRPr>
             </a:pPr>
             <a:r>
-              <a:t>After a correction, the next open finding can trigger a different evidence query.</a:t>
+              <a:t>Human correction changes the saved review; the original source remains available.</a:t>
             </a:r>
           </a:p>
         </p:txBody>
@@ -6953,7 +6723,7 @@
               </a:defRPr>
             </a:pPr>
             <a:r>
-              <a:t>Sponsor tools have jobs in the review</a:t>
+              <a:t>Sponsor contribution: proof and remaining gate</a:t>
             </a:r>
           </a:p>
         </p:txBody>
@@ -6992,7 +6762,7 @@
               </a:defRPr>
             </a:pPr>
             <a:r>
-              <a:t>Five-table import and two adaptive follow-up branches verified against live Zetaris tables; filming pending.</a:t>
+              <a:t>The product combines identified source queries with an event history and a bounded model route.</a:t>
             </a:r>
           </a:p>
         </p:txBody>
@@ -7044,8 +6814,8 @@
         </p:nvSpPr>
         <p:spPr>
           <a:xfrm>
-            <a:off x="658368" y="1764792"/>
-            <a:ext cx="5349240" cy="4160520"/>
+            <a:off x="548640" y="1764792"/>
+            <a:ext cx="3584448" cy="4160520"/>
           </a:xfrm>
           <a:prstGeom prst="roundRect">
             <a:avLst>
@@ -7089,7 +6859,7 @@
         </p:nvSpPr>
         <p:spPr>
           <a:xfrm>
-            <a:off x="658368" y="1764792"/>
+            <a:off x="548640" y="1764792"/>
             <a:ext cx="73152" cy="4160520"/>
           </a:xfrm>
           <a:prstGeom prst="rect">
@@ -7132,8 +6902,8 @@
         </p:nvSpPr>
         <p:spPr>
           <a:xfrm>
-            <a:off x="914400" y="1993391"/>
-            <a:ext cx="4846320" cy="566928"/>
+            <a:off x="804672" y="1993391"/>
+            <a:ext cx="3081528" cy="566928"/>
           </a:xfrm>
           <a:prstGeom prst="rect">
             <a:avLst/>
@@ -7171,8 +6941,8 @@
         </p:nvSpPr>
         <p:spPr>
           <a:xfrm>
-            <a:off x="914400" y="2633472"/>
-            <a:ext cx="4846320" cy="3108960"/>
+            <a:off x="804672" y="2633472"/>
+            <a:ext cx="3081528" cy="3108960"/>
           </a:xfrm>
           <a:prstGeom prst="rect">
             <a:avLst/>
@@ -7197,36 +6967,7 @@
               </a:defRPr>
             </a:pPr>
             <a:r>
-              <a:t>Fifteen live requests read five registered tables: 4 timesheets, 1 receipt, 8 activities, and 4 rows from each draft.</a:t>
-            </a:r>
-          </a:p>
-          <a:p>
-            <a:pPr>
-              <a:spcAft>
-                <a:spcPts val="700"/>
-              </a:spcAft>
-              <a:defRPr sz="1700" b="0">
-                <a:solidFill>
-                  <a:srgbClr val="1F343F"/>
-                </a:solidFill>
-                <a:latin typeface="Aptos"/>
-              </a:defRPr>
-            </a:pPr>
-          </a:p>
-          <a:p>
-            <a:pPr>
-              <a:spcAft>
-                <a:spcPts val="700"/>
-              </a:spcAft>
-              <a:defRPr sz="1700" b="0">
-                <a:solidFill>
-                  <a:srgbClr val="1F343F"/>
-                </a:solidFill>
-                <a:latin typeface="Aptos"/>
-              </a:defRPr>
-            </a:pPr>
-            <a:r>
-              <a:t>The `OVERALLOCATED_SOURCE` finding retained the timesheet table's source key and snapshot hash.</a:t>
+              <a:t>Five registered synthetic grant tables were queried live. Source keys, row counts, snapshot hashes and request IDs stay with the review.</a:t>
             </a:r>
           </a:p>
         </p:txBody>
@@ -7239,8 +6980,8 @@
         </p:nvSpPr>
         <p:spPr>
           <a:xfrm>
-            <a:off x="6190488" y="1764792"/>
-            <a:ext cx="5349240" cy="4160520"/>
+            <a:off x="4315968" y="1764792"/>
+            <a:ext cx="3584448" cy="4160520"/>
           </a:xfrm>
           <a:prstGeom prst="roundRect">
             <a:avLst>
@@ -7284,7 +7025,7 @@
         </p:nvSpPr>
         <p:spPr>
           <a:xfrm>
-            <a:off x="6190488" y="1764792"/>
+            <a:off x="4315968" y="1764792"/>
             <a:ext cx="73152" cy="4160520"/>
           </a:xfrm>
           <a:prstGeom prst="rect">
@@ -7327,8 +7068,8 @@
         </p:nvSpPr>
         <p:spPr>
           <a:xfrm>
-            <a:off x="6446520" y="1993391"/>
-            <a:ext cx="4846320" cy="566928"/>
+            <a:off x="4572000" y="1993391"/>
+            <a:ext cx="3081528" cy="566928"/>
           </a:xfrm>
           <a:prstGeom prst="rect">
             <a:avLst/>
@@ -7353,7 +7094,7 @@
               </a:defRPr>
             </a:pPr>
             <a:r>
-              <a:t>Meterless</a:t>
+              <a:t>Meterless Engine</a:t>
             </a:r>
           </a:p>
         </p:txBody>
@@ -7366,8 +7107,8 @@
         </p:nvSpPr>
         <p:spPr>
           <a:xfrm>
-            <a:off x="6446520" y="2633472"/>
-            <a:ext cx="4846320" cy="3108960"/>
+            <a:off x="4572000" y="2633472"/>
+            <a:ext cx="3081528" cy="3108960"/>
           </a:xfrm>
           <a:prstGeom prst="rect">
             <a:avLst/>
@@ -7392,9 +7133,159 @@
               </a:defRPr>
             </a:pPr>
             <a:r>
-              <a:t>The same Lens run wrote a finding ID to the local World Model reference runtime. After app restart, five findings persisted and a fresh Meterless audit returned 39 events.</a:t>
-            </a:r>
-          </a:p>
+              <a:t>World Model reference runtime stores linked sources, findings and reviewer actions. A fresh process can rebuild the history.</a:t>
+            </a:r>
+          </a:p>
+        </p:txBody>
+      </p:sp>
+      <p:sp>
+        <p:nvSpPr>
+          <p:cNvPr id="14" name="Rounded Rectangle 13"/>
+          <p:cNvSpPr/>
+          <p:nvPr/>
+        </p:nvSpPr>
+        <p:spPr>
+          <a:xfrm>
+            <a:off x="8083296" y="1764792"/>
+            <a:ext cx="3584448" cy="4160520"/>
+          </a:xfrm>
+          <a:prstGeom prst="roundRect">
+            <a:avLst>
+              <a:gd name="adj" fmla="val 12000"/>
+            </a:avLst>
+          </a:prstGeom>
+          <a:solidFill>
+            <a:srgbClr val="FFFFFF"/>
+          </a:solidFill>
+          <a:ln>
+            <a:noFill/>
+          </a:ln>
+        </p:spPr>
+        <p:style>
+          <a:lnRef idx="1">
+            <a:schemeClr val="accent1"/>
+          </a:lnRef>
+          <a:fillRef idx="3">
+            <a:schemeClr val="accent1"/>
+          </a:fillRef>
+          <a:effectRef idx="2">
+            <a:schemeClr val="accent1"/>
+          </a:effectRef>
+          <a:fontRef idx="minor">
+            <a:schemeClr val="lt1"/>
+          </a:fontRef>
+        </p:style>
+        <p:txBody>
+          <a:bodyPr rtlCol="0" anchor="ctr"/>
+          <a:lstStyle/>
+          <a:p>
+            <a:pPr algn="ctr"/>
+          </a:p>
+        </p:txBody>
+      </p:sp>
+      <p:sp>
+        <p:nvSpPr>
+          <p:cNvPr id="15" name="Rectangle 14"/>
+          <p:cNvSpPr/>
+          <p:nvPr/>
+        </p:nvSpPr>
+        <p:spPr>
+          <a:xfrm>
+            <a:off x="8083296" y="1764792"/>
+            <a:ext cx="73152" cy="4160520"/>
+          </a:xfrm>
+          <a:prstGeom prst="rect">
+            <a:avLst/>
+          </a:prstGeom>
+          <a:solidFill>
+            <a:srgbClr val="B4602A"/>
+          </a:solidFill>
+          <a:ln>
+            <a:noFill/>
+          </a:ln>
+        </p:spPr>
+        <p:style>
+          <a:lnRef idx="1">
+            <a:schemeClr val="accent1"/>
+          </a:lnRef>
+          <a:fillRef idx="3">
+            <a:schemeClr val="accent1"/>
+          </a:fillRef>
+          <a:effectRef idx="2">
+            <a:schemeClr val="accent1"/>
+          </a:effectRef>
+          <a:fontRef idx="minor">
+            <a:schemeClr val="lt1"/>
+          </a:fontRef>
+        </p:style>
+        <p:txBody>
+          <a:bodyPr rtlCol="0" anchor="ctr"/>
+          <a:lstStyle/>
+          <a:p>
+            <a:pPr algn="ctr"/>
+          </a:p>
+        </p:txBody>
+      </p:sp>
+      <p:sp>
+        <p:nvSpPr>
+          <p:cNvPr id="16" name="TextBox 15"/>
+          <p:cNvSpPr txBox="1"/>
+          <p:nvPr/>
+        </p:nvSpPr>
+        <p:spPr>
+          <a:xfrm>
+            <a:off x="8339327" y="1993391"/>
+            <a:ext cx="3081528" cy="566928"/>
+          </a:xfrm>
+          <a:prstGeom prst="rect">
+            <a:avLst/>
+          </a:prstGeom>
+          <a:noFill/>
+        </p:spPr>
+        <p:txBody>
+          <a:bodyPr wrap="square" lIns="0" rIns="0" tIns="0" bIns="0">
+            <a:spAutoFit/>
+          </a:bodyPr>
+          <a:lstStyle/>
+          <a:p>
+            <a:pPr>
+              <a:spcAft>
+                <a:spcPts val="700"/>
+              </a:spcAft>
+              <a:defRPr sz="2100" b="1">
+                <a:solidFill>
+                  <a:srgbClr val="122331"/>
+                </a:solidFill>
+                <a:latin typeface="Aptos"/>
+              </a:defRPr>
+            </a:pPr>
+            <a:r>
+              <a:t>Nightshift</a:t>
+            </a:r>
+          </a:p>
+        </p:txBody>
+      </p:sp>
+      <p:sp>
+        <p:nvSpPr>
+          <p:cNvPr id="17" name="TextBox 16"/>
+          <p:cNvSpPr txBox="1"/>
+          <p:nvPr/>
+        </p:nvSpPr>
+        <p:spPr>
+          <a:xfrm>
+            <a:off x="8339327" y="2633472"/>
+            <a:ext cx="3081528" cy="3108960"/>
+          </a:xfrm>
+          <a:prstGeom prst="rect">
+            <a:avLst/>
+          </a:prstGeom>
+          <a:noFill/>
+        </p:spPr>
+        <p:txBody>
+          <a:bodyPr wrap="square" lIns="0" rIns="0" tIns="0" bIns="0">
+            <a:spAutoFit/>
+          </a:bodyPr>
+          <a:lstStyle/>
           <a:p>
             <a:pPr>
               <a:spcAft>
@@ -7407,21 +7298,8 @@
                 <a:latin typeface="Aptos"/>
               </a:defRPr>
             </a:pPr>
-          </a:p>
-          <a:p>
-            <a:pPr>
-              <a:spcAft>
-                <a:spcPts val="700"/>
-              </a:spcAft>
-              <a:defRPr sz="1700" b="0">
-                <a:solidFill>
-                  <a:srgbClr val="1F343F"/>
-                </a:solidFill>
-                <a:latin typeface="Aptos"/>
-              </a:defRPr>
-            </a:pPr>
-            <a:r>
-              <a:t>Film the restart and human correction on the same review.</a:t>
+            <a:r>
+              <a:t>The provider adapter asks a model to prioritize an open question. A real hotspot request and response remain unverified.</a:t>
             </a:r>
           </a:p>
         </p:txBody>
@@ -7773,7 +7651,7 @@
               </a:defRPr>
             </a:pPr>
             <a:r>
-              <a:t>CSV inputs; cross-grant staff time and receipt allocations; activity-record gaps; human correction or explanation; saved local review; JSON export.</a:t>
+              <a:t>Five structured CSV inputs or owner-controlled Zetaris tables; cross-grant allocation checks; activity gaps; Google sign-in; saved reviews; JSON export.</a:t>
             </a:r>
           </a:p>
         </p:txBody>
@@ -7939,7 +7817,7 @@
               </a:defRPr>
             </a:pPr>
             <a:r>
-              <a:t>Funder templates and document imports; accounting connectors; access control for real records; grant-specific reporting rules; collaboration.</a:t>
+              <a:t>Funder templates and document imports; accounting connectors; grant-specific reporting terms; collaboration and broader real-record access controls.</a:t>
             </a:r>
           </a:p>
         </p:txBody>

</xml_diff>